<commit_message>
feat: link roadshow artifacts
</commit_message>
<xml_diff>
--- a/docs/roadshow/格致SciZhi-路演-15页-优化版.pptx
+++ b/docs/roadshow/格致SciZhi-路演-15页-优化版.pptx
@@ -4145,7 +4145,42 @@
                 <a:ea typeface="Microsoft YaHei" pitchFamily="34" charset="-122"/>
                 <a:cs typeface="Microsoft YaHei" pitchFamily="34" charset="-120"/>
               </a:rPr>
-              <a:t>持续更新仓库  ·  github.com/abzzyyxcpht/gezhi-scizhi  ·  Apache-2.0  ·  README / CHANGELOG / CI</a:t>
+              <a:t>持续更新仓库  ·  </a:t>
+            </a:r>
+            <a:pPr indent="0" marL="0">
+              <a:buNone/>
+            </a:pPr>
+            <a:r>
+              <a:rPr lang="en-US" sz="910" b="1" u="sng" dirty="0">
+                <a:solidFill>
+                  <a:srgbClr val="286557"/>
+                </a:solidFill>
+                <a:latin typeface="Microsoft YaHei" pitchFamily="34" charset="0"/>
+                <a:ea typeface="Microsoft YaHei" pitchFamily="34" charset="-122"/>
+                <a:cs typeface="Microsoft YaHei" pitchFamily="34" charset="-120"/>
+                <a:hlinkClick r:id="rId2" invalidUrl="" action="" tgtFrame="" tooltip="" history="1" highlightClick="0" endSnd="0">
+                  <a:extLst>
+                    <a:ext uri="{A12FA001-AC4F-418D-AE19-62706E023703}">
+                      <ahyp:hlinkClr xmlns:ahyp="http://schemas.microsoft.com/office/drawing/2018/hyperlinkcolor" val="tx"/>
+                    </a:ext>
+                  </a:extLst>
+                </a:hlinkClick>
+              </a:rPr>
+              <a:t>github.com/abzzyyxcpht/gezhi-scizhi</a:t>
+            </a:r>
+            <a:pPr indent="0" marL="0">
+              <a:buNone/>
+            </a:pPr>
+            <a:r>
+              <a:rPr lang="en-US" sz="910" b="1" dirty="0">
+                <a:solidFill>
+                  <a:srgbClr val="286557"/>
+                </a:solidFill>
+                <a:latin typeface="Microsoft YaHei" pitchFamily="34" charset="0"/>
+                <a:ea typeface="Microsoft YaHei" pitchFamily="34" charset="-122"/>
+                <a:cs typeface="Microsoft YaHei" pitchFamily="34" charset="-120"/>
+              </a:rPr>
+              <a:t>  ·  Apache-2.0  ·  README / CHANGELOG / CI</a:t>
             </a:r>
             <a:endParaRPr lang="en-US" sz="910" dirty="0"/>
           </a:p>

</xml_diff>